<commit_message>
Slides: sd-07-001/002/009/017 decks match the corrected lessons
Co-Authored-By: Claude Sonnet 5.5 <noreply@anthropic.com>
Claude-Session: https://claude.ai/code/session_018RBAP3SsKhvtibJN3EdchF
</commit_message>
<xml_diff>
--- a/system-design-101/vi/lessons/sd-07-001/slides/sd-07-001.pptx
+++ b/system-design-101/vi/lessons/sd-07-001/slides/sd-07-001.pptx
@@ -12137,11 +12137,11 @@
         <p:spPr>
           <a:xfrm>
             <a:off x="914400" y="5619750"/>
-            <a:ext cx="8001000" cy="2381250"/>
+            <a:ext cx="8001000" cy="3429000"/>
           </a:xfrm>
           <a:prstGeom prst="roundRect">
             <a:avLst>
-              <a:gd name="adj" fmla="val 12800"/>
+              <a:gd name="adj" fmla="val 8889"/>
             </a:avLst>
           </a:prstGeom>
           <a:solidFill>
@@ -12377,11 +12377,11 @@
         <p:spPr>
           <a:xfrm>
             <a:off x="9372600" y="5619750"/>
-            <a:ext cx="8001000" cy="2381250"/>
+            <a:ext cx="8001000" cy="3429000"/>
           </a:xfrm>
           <a:prstGeom prst="roundRect">
             <a:avLst>
-              <a:gd name="adj" fmla="val 12800"/>
+              <a:gd name="adj" fmla="val 8889"/>
             </a:avLst>
           </a:prstGeom>
           <a:solidFill>
@@ -12426,7 +12426,7 @@
               <a:t>SUY</a:t>
             </a:r>
             <a:r>
-              <a:rPr lang="en-US" sz="2100" b="1" spc="139" kern="0" dirty="0">
+              <a:rPr lang="en-US" sz="2100" b="1" spc="141" kern="0" dirty="0">
                 <a:solidFill>
                   <a:srgbClr val="FF6A4D"/>
                 </a:solidFill>
@@ -12434,10 +12434,10 @@
                 <a:ea typeface="Be Vietnam Pro" pitchFamily="34" charset="-122"/>
                 <a:cs typeface="Be Vietnam Pro" pitchFamily="34" charset="-120"/>
               </a:rPr>
-              <a:t> LUẬN</a:t>
-            </a:r>
-            <a:r>
-              <a:rPr lang="en-US" sz="2100" b="1" spc="138" kern="0" dirty="0">
+              <a:t> LUẬN,</a:t>
+            </a:r>
+            <a:r>
+              <a:rPr lang="en-US" sz="2100" b="1" spc="150" kern="0" dirty="0">
                 <a:solidFill>
                   <a:srgbClr val="FF6A4D"/>
                 </a:solidFill>
@@ -12445,7 +12445,18 @@
                 <a:ea typeface="Be Vietnam Pro" pitchFamily="34" charset="-122"/>
                 <a:cs typeface="Be Vietnam Pro" pitchFamily="34" charset="-120"/>
               </a:rPr>
-              <a:t> CỦA</a:t>
+              <a:t> CHỈ</a:t>
+            </a:r>
+            <a:r>
+              <a:rPr lang="en-US" sz="2100" b="1" spc="148" kern="0" dirty="0">
+                <a:solidFill>
+                  <a:srgbClr val="FF6A4D"/>
+                </a:solidFill>
+                <a:latin typeface="Be Vietnam Pro" pitchFamily="34" charset="0"/>
+                <a:ea typeface="Be Vietnam Pro" pitchFamily="34" charset="-122"/>
+                <a:cs typeface="Be Vietnam Pro" pitchFamily="34" charset="-120"/>
+              </a:rPr>
+              <a:t> KHI</a:t>
             </a:r>
             <a:r>
               <a:rPr lang="en-US" sz="2100" b="1" spc="149" kern="0" dirty="0">
@@ -12456,10 +12467,10 @@
                 <a:ea typeface="Be Vietnam Pro" pitchFamily="34" charset="-122"/>
                 <a:cs typeface="Be Vietnam Pro" pitchFamily="34" charset="-120"/>
               </a:rPr>
-              <a:t> NGƯỜI</a:t>
-            </a:r>
-            <a:r>
-              <a:rPr lang="en-US" sz="2100" b="1" spc="147" kern="0" dirty="0">
+              <a:t> ĐỦ HAI</a:t>
+            </a:r>
+            <a:r>
+              <a:rPr lang="en-US" sz="2100" b="1" spc="146" kern="0" dirty="0">
                 <a:solidFill>
                   <a:srgbClr val="FF6A4D"/>
                 </a:solidFill>
@@ -12467,10 +12478,10 @@
                 <a:ea typeface="Be Vietnam Pro" pitchFamily="34" charset="-122"/>
                 <a:cs typeface="Be Vietnam Pro" pitchFamily="34" charset="-120"/>
               </a:rPr>
-              <a:t> BIÊN</a:t>
-            </a:r>
-            <a:r>
-              <a:rPr lang="en-US" sz="2100" b="1" spc="137" kern="0" dirty="0">
+              <a:t> ĐIỀU</a:t>
+            </a:r>
+            <a:r>
+              <a:rPr lang="en-US" sz="2100" b="1" spc="148" kern="0" dirty="0">
                 <a:solidFill>
                   <a:srgbClr val="FF6A4D"/>
                 </a:solidFill>
@@ -12478,7 +12489,7 @@
                 <a:ea typeface="Be Vietnam Pro" pitchFamily="34" charset="-122"/>
                 <a:cs typeface="Be Vietnam Pro" pitchFamily="34" charset="-120"/>
               </a:rPr>
-              <a:t> SOẠN</a:t>
+              <a:t> KIỆN</a:t>
             </a:r>
             <a:endParaRPr lang="en-US" sz="2100" dirty="0"/>
           </a:p>
@@ -12493,7 +12504,7 @@
         <p:spPr>
           <a:xfrm>
             <a:off x="9753600" y="6419850"/>
-            <a:ext cx="7239000" cy="1333500"/>
+            <a:ext cx="7239000" cy="2571750"/>
           </a:xfrm>
           <a:prstGeom prst="rect">
             <a:avLst/>
@@ -12502,126 +12513,359 @@
           <a:ln/>
         </p:spPr>
         <p:txBody>
-          <a:bodyPr wrap="square" lIns="0" tIns="18859" rIns="0" bIns="-18859" rtlCol="0" anchor="t"/>
+          <a:bodyPr wrap="square" lIns="0" tIns="16764" rIns="0" bIns="-16764" rtlCol="0" anchor="t"/>
           <a:lstStyle/>
           <a:p>
             <a:pPr algn="l" indent="0" marL="0">
               <a:lnSpc>
-                <a:spcPts val="3375"/>
+                <a:spcPts val="3000"/>
+              </a:lnSpc>
+              <a:spcAft>
+                <a:spcPts val="900"/>
+              </a:spcAft>
+              <a:buNone/>
+            </a:pPr>
+            <a:r>
+              <a:rPr lang="en-US" sz="2400" b="1" dirty="0" spc="3" kern="0">
+                <a:solidFill>
+                  <a:srgbClr val="F3EEE3"/>
+                </a:solidFill>
+                <a:latin typeface="Be Vietnam Pro" pitchFamily="34" charset="0"/>
+                <a:ea typeface="Be Vietnam Pro" pitchFamily="34" charset="-122"/>
+                <a:cs typeface="Be Vietnam Pro" pitchFamily="34" charset="-120"/>
+              </a:rPr>
+              <a:t>•</a:t>
+            </a:r>
+            <a:r>
+              <a:rPr lang="en-US" sz="2400" b="1" dirty="0" spc="0" kern="0">
+                <a:solidFill>
+                  <a:srgbClr val="F3EEE3"/>
+                </a:solidFill>
+                <a:latin typeface="Be Vietnam Pro" pitchFamily="34" charset="0"/>
+                <a:ea typeface="Be Vietnam Pro" pitchFamily="34" charset="-122"/>
+                <a:cs typeface="Be Vietnam Pro" pitchFamily="34" charset="-120"/>
+              </a:rPr>
+              <a:t> Giữ</a:t>
+            </a:r>
+            <a:r>
+              <a:rPr lang="en-US" sz="2400" b="1" dirty="0" spc="-3" kern="0">
+                <a:solidFill>
+                  <a:srgbClr val="F3EEE3"/>
+                </a:solidFill>
+                <a:latin typeface="Be Vietnam Pro" pitchFamily="34" charset="0"/>
+                <a:ea typeface="Be Vietnam Pro" pitchFamily="34" charset="-122"/>
+                <a:cs typeface="Be Vietnam Pro" pitchFamily="34" charset="-120"/>
+              </a:rPr>
+              <a:t> chỗ</a:t>
+            </a:r>
+            <a:r>
+              <a:rPr lang="en-US" sz="2400" b="1" dirty="0" spc="-2" kern="0">
+                <a:solidFill>
+                  <a:srgbClr val="F3EEE3"/>
+                </a:solidFill>
+                <a:latin typeface="Be Vietnam Pro" pitchFamily="34" charset="0"/>
+                <a:ea typeface="Be Vietnam Pro" pitchFamily="34" charset="-122"/>
+                <a:cs typeface="Be Vietnam Pro" pitchFamily="34" charset="-120"/>
+              </a:rPr>
+              <a:t> là</a:t>
+            </a:r>
+            <a:r>
+              <a:rPr lang="en-US" sz="2400" b="1" dirty="0" spc="-8" kern="0">
+                <a:solidFill>
+                  <a:srgbClr val="F3EEE3"/>
+                </a:solidFill>
+                <a:latin typeface="Be Vietnam Pro" pitchFamily="34" charset="0"/>
+                <a:ea typeface="Be Vietnam Pro" pitchFamily="34" charset="-122"/>
+                <a:cs typeface="Be Vietnam Pro" pitchFamily="34" charset="-120"/>
+              </a:rPr>
+              <a:t> một</a:t>
+            </a:r>
+            <a:r>
+              <a:rPr lang="en-US" sz="2400" b="1" dirty="0" spc="2" kern="0">
+                <a:solidFill>
+                  <a:srgbClr val="F3EEE3"/>
+                </a:solidFill>
+                <a:latin typeface="Be Vietnam Pro" pitchFamily="34" charset="0"/>
+                <a:ea typeface="Be Vietnam Pro" pitchFamily="34" charset="-122"/>
+                <a:cs typeface="Be Vietnam Pro" pitchFamily="34" charset="-120"/>
+              </a:rPr>
+              <a:t> thao</a:t>
+            </a:r>
+            <a:r>
+              <a:rPr lang="en-US" sz="2400" b="1" dirty="0" spc="0" kern="0">
+                <a:solidFill>
+                  <a:srgbClr val="F3EEE3"/>
+                </a:solidFill>
+                <a:latin typeface="Be Vietnam Pro" pitchFamily="34" charset="0"/>
+                <a:ea typeface="Be Vietnam Pro" pitchFamily="34" charset="-122"/>
+                <a:cs typeface="Be Vietnam Pro" pitchFamily="34" charset="-120"/>
+              </a:rPr>
+              <a:t> tác</a:t>
+            </a:r>
+            <a:r>
+              <a:rPr lang="en-US" sz="2400" b="1" dirty="0" spc="-12" kern="0">
+                <a:solidFill>
+                  <a:srgbClr val="F3EEE3"/>
+                </a:solidFill>
+                <a:latin typeface="Be Vietnam Pro" pitchFamily="34" charset="0"/>
+                <a:ea typeface="Be Vietnam Pro" pitchFamily="34" charset="-122"/>
+                <a:cs typeface="Be Vietnam Pro" pitchFamily="34" charset="-120"/>
+              </a:rPr>
+              <a:t> trọn</a:t>
+            </a:r>
+            <a:r>
+              <a:rPr lang="en-US" sz="2400" b="1" dirty="0" spc="-20" kern="0">
+                <a:solidFill>
+                  <a:srgbClr val="F3EEE3"/>
+                </a:solidFill>
+                <a:latin typeface="Be Vietnam Pro" pitchFamily="34" charset="0"/>
+                <a:ea typeface="Be Vietnam Pro" pitchFamily="34" charset="-122"/>
+                <a:cs typeface="Be Vietnam Pro" pitchFamily="34" charset="-120"/>
+              </a:rPr>
+              <a:t> vẹn</a:t>
+            </a:r>
+            <a:endParaRPr lang="en-US" sz="2400" dirty="0"/>
+          </a:p>
+          <a:p>
+            <a:pPr algn="l" indent="0" marL="0">
+              <a:lnSpc>
+                <a:spcPts val="3000"/>
+              </a:lnSpc>
+              <a:spcAft>
+                <a:spcPts val="900"/>
+              </a:spcAft>
+              <a:buNone/>
+            </a:pPr>
+            <a:r>
+              <a:rPr lang="en-US" sz="2400" b="1" dirty="0" spc="3" kern="0">
+                <a:solidFill>
+                  <a:srgbClr val="F3EEE3"/>
+                </a:solidFill>
+                <a:latin typeface="Be Vietnam Pro" pitchFamily="34" charset="0"/>
+                <a:ea typeface="Be Vietnam Pro" pitchFamily="34" charset="-122"/>
+                <a:cs typeface="Be Vietnam Pro" pitchFamily="34" charset="-120"/>
+              </a:rPr>
+              <a:t>•</a:t>
+            </a:r>
+            <a:r>
+              <a:rPr lang="en-US" sz="2400" b="1" dirty="0" spc="-4" kern="0">
+                <a:solidFill>
+                  <a:srgbClr val="F3EEE3"/>
+                </a:solidFill>
+                <a:latin typeface="Be Vietnam Pro" pitchFamily="34" charset="0"/>
+                <a:ea typeface="Be Vietnam Pro" pitchFamily="34" charset="-122"/>
+                <a:cs typeface="Be Vietnam Pro" pitchFamily="34" charset="-120"/>
+              </a:rPr>
+              <a:t> Chỗ</a:t>
+            </a:r>
+            <a:r>
+              <a:rPr lang="en-US" sz="2400" b="1" dirty="0" spc="0" kern="0">
+                <a:solidFill>
+                  <a:srgbClr val="F3EEE3"/>
+                </a:solidFill>
+                <a:latin typeface="Be Vietnam Pro" pitchFamily="34" charset="0"/>
+                <a:ea typeface="Be Vietnam Pro" pitchFamily="34" charset="-122"/>
+                <a:cs typeface="Be Vietnam Pro" pitchFamily="34" charset="-120"/>
+              </a:rPr>
+              <a:t> giữ</a:t>
+            </a:r>
+            <a:r>
+              <a:rPr lang="en-US" sz="2400" b="1" dirty="0" spc="-7" kern="0">
+                <a:solidFill>
+                  <a:srgbClr val="F3EEE3"/>
+                </a:solidFill>
+                <a:latin typeface="Be Vietnam Pro" pitchFamily="34" charset="0"/>
+                <a:ea typeface="Be Vietnam Pro" pitchFamily="34" charset="-122"/>
+                <a:cs typeface="Be Vietnam Pro" pitchFamily="34" charset="-120"/>
+              </a:rPr>
+              <a:t> còn</a:t>
+            </a:r>
+            <a:r>
+              <a:rPr lang="en-US" sz="2400" b="1" dirty="0" spc="-2" kern="0">
+                <a:solidFill>
+                  <a:srgbClr val="F3EEE3"/>
+                </a:solidFill>
+                <a:latin typeface="Be Vietnam Pro" pitchFamily="34" charset="0"/>
+                <a:ea typeface="Be Vietnam Pro" pitchFamily="34" charset="-122"/>
+                <a:cs typeface="Be Vietnam Pro" pitchFamily="34" charset="-120"/>
+              </a:rPr>
+              <a:t> hiệu</a:t>
+            </a:r>
+            <a:r>
+              <a:rPr lang="en-US" sz="2400" b="1" dirty="0" spc="15" kern="0">
+                <a:solidFill>
+                  <a:srgbClr val="F3EEE3"/>
+                </a:solidFill>
+                <a:latin typeface="Be Vietnam Pro" pitchFamily="34" charset="0"/>
+                <a:ea typeface="Be Vietnam Pro" pitchFamily="34" charset="-122"/>
+                <a:cs typeface="Be Vietnam Pro" pitchFamily="34" charset="-120"/>
+              </a:rPr>
+              <a:t> lực</a:t>
+            </a:r>
+            <a:r>
+              <a:rPr lang="en-US" sz="2400" b="1" dirty="0" spc="2" kern="0">
+                <a:solidFill>
+                  <a:srgbClr val="F3EEE3"/>
+                </a:solidFill>
+                <a:latin typeface="Be Vietnam Pro" pitchFamily="34" charset="0"/>
+                <a:ea typeface="Be Vietnam Pro" pitchFamily="34" charset="-122"/>
+                <a:cs typeface="Be Vietnam Pro" pitchFamily="34" charset="-120"/>
+              </a:rPr>
+              <a:t> tới</a:t>
+            </a:r>
+            <a:r>
+              <a:rPr lang="en-US" sz="2400" b="1" dirty="0" spc="-1" kern="0">
+                <a:solidFill>
+                  <a:srgbClr val="F3EEE3"/>
+                </a:solidFill>
+                <a:latin typeface="Be Vietnam Pro" pitchFamily="34" charset="0"/>
+                <a:ea typeface="Be Vietnam Pro" pitchFamily="34" charset="-122"/>
+                <a:cs typeface="Be Vietnam Pro" pitchFamily="34" charset="-120"/>
+              </a:rPr>
+              <a:t> khi</a:t>
+            </a:r>
+            <a:r>
+              <a:rPr lang="en-US" sz="2400" b="1" dirty="0" spc="-10" kern="0">
+                <a:solidFill>
+                  <a:srgbClr val="F3EEE3"/>
+                </a:solidFill>
+                <a:latin typeface="Be Vietnam Pro" pitchFamily="34" charset="0"/>
+                <a:ea typeface="Be Vietnam Pro" pitchFamily="34" charset="-122"/>
+                <a:cs typeface="Be Vietnam Pro" pitchFamily="34" charset="-120"/>
+              </a:rPr>
+              <a:t> trả</a:t>
+            </a:r>
+            <a:r>
+              <a:rPr lang="en-US" sz="2400" b="1" dirty="0" spc="-24" kern="0">
+                <a:solidFill>
+                  <a:srgbClr val="F3EEE3"/>
+                </a:solidFill>
+                <a:latin typeface="Be Vietnam Pro" pitchFamily="34" charset="0"/>
+                <a:ea typeface="Be Vietnam Pro" pitchFamily="34" charset="-122"/>
+                <a:cs typeface="Be Vietnam Pro" pitchFamily="34" charset="-120"/>
+              </a:rPr>
+              <a:t> xong</a:t>
+            </a:r>
+            <a:endParaRPr lang="en-US" sz="2400" dirty="0"/>
+          </a:p>
+          <a:p>
+            <a:pPr algn="l" indent="0" marL="0">
+              <a:lnSpc>
+                <a:spcPts val="3000"/>
               </a:lnSpc>
               <a:buNone/>
             </a:pPr>
             <a:r>
-              <a:rPr lang="en-US" sz="2700" b="1" dirty="0" spc="-3" kern="0">
-                <a:solidFill>
-                  <a:srgbClr val="F3EEE3"/>
-                </a:solidFill>
-                <a:latin typeface="Be Vietnam Pro" pitchFamily="34" charset="0"/>
-                <a:ea typeface="Be Vietnam Pro" pitchFamily="34" charset="-122"/>
-                <a:cs typeface="Be Vietnam Pro" pitchFamily="34" charset="-120"/>
-              </a:rPr>
-              <a:t>Giữ</a:t>
-            </a:r>
-            <a:r>
-              <a:rPr lang="en-US" sz="2700" b="1" dirty="0" spc="-4" kern="0">
-                <a:solidFill>
-                  <a:srgbClr val="F3EEE3"/>
-                </a:solidFill>
-                <a:latin typeface="Be Vietnam Pro" pitchFamily="34" charset="0"/>
-                <a:ea typeface="Be Vietnam Pro" pitchFamily="34" charset="-122"/>
-                <a:cs typeface="Be Vietnam Pro" pitchFamily="34" charset="-120"/>
-              </a:rPr>
-              <a:t> chỗ</a:t>
-            </a:r>
-            <a:r>
-              <a:rPr lang="en-US" sz="2700" b="1" dirty="0" spc="7" kern="0">
-                <a:solidFill>
-                  <a:srgbClr val="F3EEE3"/>
-                </a:solidFill>
-                <a:latin typeface="Be Vietnam Pro" pitchFamily="34" charset="0"/>
-                <a:ea typeface="Be Vietnam Pro" pitchFamily="34" charset="-122"/>
-                <a:cs typeface="Be Vietnam Pro" pitchFamily="34" charset="-120"/>
-              </a:rPr>
-              <a:t> trước để</a:t>
-            </a:r>
-            <a:r>
-              <a:rPr lang="en-US" sz="2700" b="1" dirty="0" spc="-2" kern="0">
-                <a:solidFill>
-                  <a:srgbClr val="F3EEE3"/>
-                </a:solidFill>
-                <a:latin typeface="Be Vietnam Pro" pitchFamily="34" charset="0"/>
-                <a:ea typeface="Be Vietnam Pro" pitchFamily="34" charset="-122"/>
-                <a:cs typeface="Be Vietnam Pro" pitchFamily="34" charset="-120"/>
-              </a:rPr>
-              <a:t> hai</a:t>
-            </a:r>
-            <a:r>
-              <a:rPr lang="en-US" sz="2700" b="1" dirty="0" spc="11" kern="0">
-                <a:solidFill>
-                  <a:srgbClr val="F3EEE3"/>
-                </a:solidFill>
-                <a:latin typeface="Be Vietnam Pro" pitchFamily="34" charset="0"/>
-                <a:ea typeface="Be Vietnam Pro" pitchFamily="34" charset="-122"/>
-                <a:cs typeface="Be Vietnam Pro" pitchFamily="34" charset="-120"/>
-              </a:rPr>
-              <a:t> người</a:t>
-            </a:r>
-            <a:r>
-              <a:rPr lang="en-US" sz="2700" b="1" dirty="0" spc="-6" kern="0">
-                <a:solidFill>
-                  <a:srgbClr val="F3EEE3"/>
-                </a:solidFill>
-                <a:latin typeface="Be Vietnam Pro" pitchFamily="34" charset="0"/>
-                <a:ea typeface="Be Vietnam Pro" pitchFamily="34" charset="-122"/>
-                <a:cs typeface="Be Vietnam Pro" pitchFamily="34" charset="-120"/>
-              </a:rPr>
-              <a:t> không</a:t>
-            </a:r>
-            <a:r>
-              <a:rPr lang="en-US" sz="2700" b="1" dirty="0" spc="-3" kern="0">
-                <a:solidFill>
-                  <a:srgbClr val="F3EEE3"/>
-                </a:solidFill>
-                <a:latin typeface="Be Vietnam Pro" pitchFamily="34" charset="0"/>
-                <a:ea typeface="Be Vietnam Pro" pitchFamily="34" charset="-122"/>
-                <a:cs typeface="Be Vietnam Pro" pitchFamily="34" charset="-120"/>
-              </a:rPr>
-              <a:t> cùng</a:t>
-            </a:r>
-            <a:r>
-              <a:rPr lang="en-US" sz="2700" b="1" dirty="0" spc="-18" kern="0">
-                <a:solidFill>
-                  <a:srgbClr val="F3EEE3"/>
-                </a:solidFill>
-                <a:latin typeface="Be Vietnam Pro" pitchFamily="34" charset="0"/>
-                <a:ea typeface="Be Vietnam Pro" pitchFamily="34" charset="-122"/>
-                <a:cs typeface="Be Vietnam Pro" pitchFamily="34" charset="-120"/>
-              </a:rPr>
-              <a:t> trả</a:t>
-            </a:r>
-            <a:r>
-              <a:rPr lang="en-US" sz="2700" b="1" dirty="0" spc="-14" kern="0">
-                <a:solidFill>
-                  <a:srgbClr val="F3EEE3"/>
-                </a:solidFill>
-                <a:latin typeface="Be Vietnam Pro" pitchFamily="34" charset="0"/>
-                <a:ea typeface="Be Vietnam Pro" pitchFamily="34" charset="-122"/>
-                <a:cs typeface="Be Vietnam Pro" pitchFamily="34" charset="-120"/>
-              </a:rPr>
-              <a:t> một</a:t>
-            </a:r>
-            <a:r>
-              <a:rPr lang="en-US" sz="2700" b="1" dirty="0" spc="-7" kern="0">
-                <a:solidFill>
-                  <a:srgbClr val="F3EEE3"/>
-                </a:solidFill>
-                <a:latin typeface="Be Vietnam Pro" pitchFamily="34" charset="0"/>
-                <a:ea typeface="Be Vietnam Pro" pitchFamily="34" charset="-122"/>
-                <a:cs typeface="Be Vietnam Pro" pitchFamily="34" charset="-120"/>
-              </a:rPr>
-              <a:t> món.</a:t>
-            </a:r>
-            <a:endParaRPr lang="en-US" sz="2700" dirty="0"/>
+              <a:rPr lang="en-US" sz="2400" b="1" dirty="0" spc="3" kern="0">
+                <a:solidFill>
+                  <a:srgbClr val="F3EEE3"/>
+                </a:solidFill>
+                <a:latin typeface="Be Vietnam Pro" pitchFamily="34" charset="0"/>
+                <a:ea typeface="Be Vietnam Pro" pitchFamily="34" charset="-122"/>
+                <a:cs typeface="Be Vietnam Pro" pitchFamily="34" charset="-120"/>
+              </a:rPr>
+              <a:t>•</a:t>
+            </a:r>
+            <a:r>
+              <a:rPr lang="en-US" sz="2400" b="1" dirty="0" spc="-4" kern="0">
+                <a:solidFill>
+                  <a:srgbClr val="F3EEE3"/>
+                </a:solidFill>
+                <a:latin typeface="Be Vietnam Pro" pitchFamily="34" charset="0"/>
+                <a:ea typeface="Be Vietnam Pro" pitchFamily="34" charset="-122"/>
+                <a:cs typeface="Be Vietnam Pro" pitchFamily="34" charset="-120"/>
+              </a:rPr>
+              <a:t> Cùng</a:t>
+            </a:r>
+            <a:r>
+              <a:rPr lang="en-US" sz="2400" b="1" dirty="0" spc="0" kern="0">
+                <a:solidFill>
+                  <a:srgbClr val="F3EEE3"/>
+                </a:solidFill>
+                <a:latin typeface="Be Vietnam Pro" pitchFamily="34" charset="0"/>
+                <a:ea typeface="Be Vietnam Pro" pitchFamily="34" charset="-122"/>
+                <a:cs typeface="Be Vietnam Pro" pitchFamily="34" charset="-120"/>
+              </a:rPr>
+              <a:t> giữ</a:t>
+            </a:r>
+            <a:r>
+              <a:rPr lang="en-US" sz="2400" b="1" dirty="0" spc="-6" kern="0">
+                <a:solidFill>
+                  <a:srgbClr val="F3EEE3"/>
+                </a:solidFill>
+                <a:latin typeface="Be Vietnam Pro" pitchFamily="34" charset="0"/>
+                <a:ea typeface="Be Vietnam Pro" pitchFamily="34" charset="-122"/>
+                <a:cs typeface="Be Vietnam Pro" pitchFamily="34" charset="-120"/>
+              </a:rPr>
+              <a:t> món</a:t>
+            </a:r>
+            <a:r>
+              <a:rPr lang="en-US" sz="2400" b="1" dirty="0" spc="1" kern="0">
+                <a:solidFill>
+                  <a:srgbClr val="F3EEE3"/>
+                </a:solidFill>
+                <a:latin typeface="Be Vietnam Pro" pitchFamily="34" charset="0"/>
+                <a:ea typeface="Be Vietnam Pro" pitchFamily="34" charset="-122"/>
+                <a:cs typeface="Be Vietnam Pro" pitchFamily="34" charset="-120"/>
+              </a:rPr>
+              <a:t> cuối,</a:t>
+            </a:r>
+            <a:r>
+              <a:rPr lang="en-US" sz="2400" b="1" dirty="0" spc="-2" kern="0">
+                <a:solidFill>
+                  <a:srgbClr val="F3EEE3"/>
+                </a:solidFill>
+                <a:latin typeface="Be Vietnam Pro" pitchFamily="34" charset="0"/>
+                <a:ea typeface="Be Vietnam Pro" pitchFamily="34" charset="-122"/>
+                <a:cs typeface="Be Vietnam Pro" pitchFamily="34" charset="-120"/>
+              </a:rPr>
+              <a:t> hoặc</a:t>
+            </a:r>
+            <a:r>
+              <a:rPr lang="en-US" sz="2400" b="1" dirty="0" spc="-10" kern="0">
+                <a:solidFill>
+                  <a:srgbClr val="F3EEE3"/>
+                </a:solidFill>
+                <a:latin typeface="Be Vietnam Pro" pitchFamily="34" charset="0"/>
+                <a:ea typeface="Be Vietnam Pro" pitchFamily="34" charset="-122"/>
+                <a:cs typeface="Be Vietnam Pro" pitchFamily="34" charset="-120"/>
+              </a:rPr>
+              <a:t> hết</a:t>
+            </a:r>
+            <a:r>
+              <a:rPr lang="en-US" sz="2400" b="1" dirty="0" spc="-1" kern="0">
+                <a:solidFill>
+                  <a:srgbClr val="F3EEE3"/>
+                </a:solidFill>
+                <a:latin typeface="Be Vietnam Pro" pitchFamily="34" charset="0"/>
+                <a:ea typeface="Be Vietnam Pro" pitchFamily="34" charset="-122"/>
+                <a:cs typeface="Be Vietnam Pro" pitchFamily="34" charset="-120"/>
+              </a:rPr>
+              <a:t> hạn:</a:t>
+            </a:r>
+            <a:r>
+              <a:rPr lang="en-US" sz="2400" b="1" dirty="0" spc="-13" kern="0">
+                <a:solidFill>
+                  <a:srgbClr val="F3EEE3"/>
+                </a:solidFill>
+                <a:latin typeface="Be Vietnam Pro" pitchFamily="34" charset="0"/>
+                <a:ea typeface="Be Vietnam Pro" pitchFamily="34" charset="-122"/>
+                <a:cs typeface="Be Vietnam Pro" pitchFamily="34" charset="-120"/>
+              </a:rPr>
+              <a:t> vẫn</a:t>
+            </a:r>
+            <a:r>
+              <a:rPr lang="en-US" sz="2400" b="1" dirty="0" spc="-1" kern="0">
+                <a:solidFill>
+                  <a:srgbClr val="F3EEE3"/>
+                </a:solidFill>
+                <a:latin typeface="Be Vietnam Pro" pitchFamily="34" charset="0"/>
+                <a:ea typeface="Be Vietnam Pro" pitchFamily="34" charset="-122"/>
+                <a:cs typeface="Be Vietnam Pro" pitchFamily="34" charset="-120"/>
+              </a:rPr>
+              <a:t> bán trùng</a:t>
+            </a:r>
+            <a:endParaRPr lang="en-US" sz="2400" dirty="0"/>
           </a:p>
         </p:txBody>
       </p:sp>

</xml_diff>